<commit_message>
Infosys Springboard Team Project
</commit_message>
<xml_diff>
--- a/ElectViz_Election_DataViz_Media.pptx
+++ b/ElectViz_Election_DataViz_Media.pptx
@@ -317,7 +317,7 @@
           <a:p>
             <a:fld id="{5BCAD085-E8A6-8845-BD4E-CB4CCA059FC4}" type="datetimeFigureOut">
               <a:rPr lang="en-US" smtClean="0"/>
-              <a:t>3/4/2026</a:t>
+              <a:t>3/5/2026</a:t>
             </a:fld>
             <a:endParaRPr lang="en-US"/>
           </a:p>
@@ -375,13 +375,13 @@
   <p:clrMapOvr>
     <a:masterClrMapping/>
   </p:clrMapOvr>
-  <mc:AlternateContent xmlns:mc="http://schemas.openxmlformats.org/markup-compatibility/2006">
-    <mc:Choice xmlns:p14="http://schemas.microsoft.com/office/powerpoint/2010/main" Requires="p14">
+  <mc:AlternateContent xmlns:mc="http://schemas.openxmlformats.org/markup-compatibility/2006" xmlns:p14="http://schemas.microsoft.com/office/powerpoint/2010/main">
+    <mc:Choice Requires="p14">
       <p:transition spd="slow" p14:dur="1250">
         <p:fade/>
       </p:transition>
     </mc:Choice>
-    <mc:Fallback>
+    <mc:Fallback xmlns="">
       <p:transition spd="slow">
         <p:fade/>
       </p:transition>
@@ -497,7 +497,7 @@
           <a:p>
             <a:fld id="{5BCAD085-E8A6-8845-BD4E-CB4CCA059FC4}" type="datetimeFigureOut">
               <a:rPr lang="en-US" smtClean="0"/>
-              <a:t>3/4/2026</a:t>
+              <a:t>3/5/2026</a:t>
             </a:fld>
             <a:endParaRPr lang="en-US"/>
           </a:p>
@@ -555,13 +555,13 @@
   <p:clrMapOvr>
     <a:masterClrMapping/>
   </p:clrMapOvr>
-  <mc:AlternateContent xmlns:mc="http://schemas.openxmlformats.org/markup-compatibility/2006">
-    <mc:Choice xmlns:p14="http://schemas.microsoft.com/office/powerpoint/2010/main" Requires="p14">
+  <mc:AlternateContent xmlns:mc="http://schemas.openxmlformats.org/markup-compatibility/2006" xmlns:p14="http://schemas.microsoft.com/office/powerpoint/2010/main">
+    <mc:Choice Requires="p14">
       <p:transition spd="slow" p14:dur="1250">
         <p:fade/>
       </p:transition>
     </mc:Choice>
-    <mc:Fallback>
+    <mc:Fallback xmlns="">
       <p:transition spd="slow">
         <p:fade/>
       </p:transition>
@@ -687,7 +687,7 @@
           <a:p>
             <a:fld id="{5BCAD085-E8A6-8845-BD4E-CB4CCA059FC4}" type="datetimeFigureOut">
               <a:rPr lang="en-US" smtClean="0"/>
-              <a:t>3/4/2026</a:t>
+              <a:t>3/5/2026</a:t>
             </a:fld>
             <a:endParaRPr lang="en-US"/>
           </a:p>
@@ -745,13 +745,13 @@
   <p:clrMapOvr>
     <a:masterClrMapping/>
   </p:clrMapOvr>
-  <mc:AlternateContent xmlns:mc="http://schemas.openxmlformats.org/markup-compatibility/2006">
-    <mc:Choice xmlns:p14="http://schemas.microsoft.com/office/powerpoint/2010/main" Requires="p14">
+  <mc:AlternateContent xmlns:mc="http://schemas.openxmlformats.org/markup-compatibility/2006" xmlns:p14="http://schemas.microsoft.com/office/powerpoint/2010/main">
+    <mc:Choice Requires="p14">
       <p:transition spd="slow" p14:dur="1250">
         <p:fade/>
       </p:transition>
     </mc:Choice>
-    <mc:Fallback>
+    <mc:Fallback xmlns="">
       <p:transition spd="slow">
         <p:fade/>
       </p:transition>
@@ -867,7 +867,7 @@
           <a:p>
             <a:fld id="{5BCAD085-E8A6-8845-BD4E-CB4CCA059FC4}" type="datetimeFigureOut">
               <a:rPr lang="en-US" smtClean="0"/>
-              <a:t>3/4/2026</a:t>
+              <a:t>3/5/2026</a:t>
             </a:fld>
             <a:endParaRPr lang="en-US"/>
           </a:p>
@@ -925,13 +925,13 @@
   <p:clrMapOvr>
     <a:masterClrMapping/>
   </p:clrMapOvr>
-  <mc:AlternateContent xmlns:mc="http://schemas.openxmlformats.org/markup-compatibility/2006">
-    <mc:Choice xmlns:p14="http://schemas.microsoft.com/office/powerpoint/2010/main" Requires="p14">
+  <mc:AlternateContent xmlns:mc="http://schemas.openxmlformats.org/markup-compatibility/2006" xmlns:p14="http://schemas.microsoft.com/office/powerpoint/2010/main">
+    <mc:Choice Requires="p14">
       <p:transition spd="slow" p14:dur="1250">
         <p:fade/>
       </p:transition>
     </mc:Choice>
-    <mc:Fallback>
+    <mc:Fallback xmlns="">
       <p:transition spd="slow">
         <p:fade/>
       </p:transition>
@@ -1124,7 +1124,7 @@
           <a:p>
             <a:fld id="{5BCAD085-E8A6-8845-BD4E-CB4CCA059FC4}" type="datetimeFigureOut">
               <a:rPr lang="en-US" smtClean="0"/>
-              <a:t>3/4/2026</a:t>
+              <a:t>3/5/2026</a:t>
             </a:fld>
             <a:endParaRPr lang="en-US"/>
           </a:p>
@@ -1182,13 +1182,13 @@
   <p:clrMapOvr>
     <a:masterClrMapping/>
   </p:clrMapOvr>
-  <mc:AlternateContent xmlns:mc="http://schemas.openxmlformats.org/markup-compatibility/2006">
-    <mc:Choice xmlns:p14="http://schemas.microsoft.com/office/powerpoint/2010/main" Requires="p14">
+  <mc:AlternateContent xmlns:mc="http://schemas.openxmlformats.org/markup-compatibility/2006" xmlns:p14="http://schemas.microsoft.com/office/powerpoint/2010/main">
+    <mc:Choice Requires="p14">
       <p:transition spd="slow" p14:dur="1250">
         <p:fade/>
       </p:transition>
     </mc:Choice>
-    <mc:Fallback>
+    <mc:Fallback xmlns="">
       <p:transition spd="slow">
         <p:fade/>
       </p:transition>
@@ -1421,7 +1421,7 @@
           <a:p>
             <a:fld id="{5BCAD085-E8A6-8845-BD4E-CB4CCA059FC4}" type="datetimeFigureOut">
               <a:rPr lang="en-US" smtClean="0"/>
-              <a:t>3/4/2026</a:t>
+              <a:t>3/5/2026</a:t>
             </a:fld>
             <a:endParaRPr lang="en-US"/>
           </a:p>
@@ -1479,13 +1479,13 @@
   <p:clrMapOvr>
     <a:masterClrMapping/>
   </p:clrMapOvr>
-  <mc:AlternateContent xmlns:mc="http://schemas.openxmlformats.org/markup-compatibility/2006">
-    <mc:Choice xmlns:p14="http://schemas.microsoft.com/office/powerpoint/2010/main" Requires="p14">
+  <mc:AlternateContent xmlns:mc="http://schemas.openxmlformats.org/markup-compatibility/2006" xmlns:p14="http://schemas.microsoft.com/office/powerpoint/2010/main">
+    <mc:Choice Requires="p14">
       <p:transition spd="slow" p14:dur="1250">
         <p:fade/>
       </p:transition>
     </mc:Choice>
-    <mc:Fallback>
+    <mc:Fallback xmlns="">
       <p:transition spd="slow">
         <p:fade/>
       </p:transition>
@@ -1852,7 +1852,7 @@
           <a:p>
             <a:fld id="{5BCAD085-E8A6-8845-BD4E-CB4CCA059FC4}" type="datetimeFigureOut">
               <a:rPr lang="en-US" smtClean="0"/>
-              <a:t>3/4/2026</a:t>
+              <a:t>3/5/2026</a:t>
             </a:fld>
             <a:endParaRPr lang="en-US"/>
           </a:p>
@@ -1910,13 +1910,13 @@
   <p:clrMapOvr>
     <a:masterClrMapping/>
   </p:clrMapOvr>
-  <mc:AlternateContent xmlns:mc="http://schemas.openxmlformats.org/markup-compatibility/2006">
-    <mc:Choice xmlns:p14="http://schemas.microsoft.com/office/powerpoint/2010/main" Requires="p14">
+  <mc:AlternateContent xmlns:mc="http://schemas.openxmlformats.org/markup-compatibility/2006" xmlns:p14="http://schemas.microsoft.com/office/powerpoint/2010/main">
+    <mc:Choice Requires="p14">
       <p:transition spd="slow" p14:dur="1250">
         <p:fade/>
       </p:transition>
     </mc:Choice>
-    <mc:Fallback>
+    <mc:Fallback xmlns="">
       <p:transition spd="slow">
         <p:fade/>
       </p:transition>
@@ -1981,7 +1981,7 @@
           <a:p>
             <a:fld id="{5BCAD085-E8A6-8845-BD4E-CB4CCA059FC4}" type="datetimeFigureOut">
               <a:rPr lang="en-US" smtClean="0"/>
-              <a:t>3/4/2026</a:t>
+              <a:t>3/5/2026</a:t>
             </a:fld>
             <a:endParaRPr lang="en-US"/>
           </a:p>
@@ -2039,13 +2039,13 @@
   <p:clrMapOvr>
     <a:masterClrMapping/>
   </p:clrMapOvr>
-  <mc:AlternateContent xmlns:mc="http://schemas.openxmlformats.org/markup-compatibility/2006">
-    <mc:Choice xmlns:p14="http://schemas.microsoft.com/office/powerpoint/2010/main" Requires="p14">
+  <mc:AlternateContent xmlns:mc="http://schemas.openxmlformats.org/markup-compatibility/2006" xmlns:p14="http://schemas.microsoft.com/office/powerpoint/2010/main">
+    <mc:Choice Requires="p14">
       <p:transition spd="slow" p14:dur="1250">
         <p:fade/>
       </p:transition>
     </mc:Choice>
-    <mc:Fallback>
+    <mc:Fallback xmlns="">
       <p:transition spd="slow">
         <p:fade/>
       </p:transition>
@@ -2088,7 +2088,7 @@
           <a:p>
             <a:fld id="{5BCAD085-E8A6-8845-BD4E-CB4CCA059FC4}" type="datetimeFigureOut">
               <a:rPr lang="en-US" smtClean="0"/>
-              <a:t>3/4/2026</a:t>
+              <a:t>3/5/2026</a:t>
             </a:fld>
             <a:endParaRPr lang="en-US"/>
           </a:p>
@@ -2146,13 +2146,13 @@
   <p:clrMapOvr>
     <a:masterClrMapping/>
   </p:clrMapOvr>
-  <mc:AlternateContent xmlns:mc="http://schemas.openxmlformats.org/markup-compatibility/2006">
-    <mc:Choice xmlns:p14="http://schemas.microsoft.com/office/powerpoint/2010/main" Requires="p14">
+  <mc:AlternateContent xmlns:mc="http://schemas.openxmlformats.org/markup-compatibility/2006" xmlns:p14="http://schemas.microsoft.com/office/powerpoint/2010/main">
+    <mc:Choice Requires="p14">
       <p:transition spd="slow" p14:dur="1250">
         <p:fade/>
       </p:transition>
     </mc:Choice>
-    <mc:Fallback>
+    <mc:Fallback xmlns="">
       <p:transition spd="slow">
         <p:fade/>
       </p:transition>
@@ -2375,7 +2375,7 @@
           <a:p>
             <a:fld id="{5BCAD085-E8A6-8845-BD4E-CB4CCA059FC4}" type="datetimeFigureOut">
               <a:rPr lang="en-US" smtClean="0"/>
-              <a:t>3/4/2026</a:t>
+              <a:t>3/5/2026</a:t>
             </a:fld>
             <a:endParaRPr lang="en-US"/>
           </a:p>
@@ -2433,13 +2433,13 @@
   <p:clrMapOvr>
     <a:masterClrMapping/>
   </p:clrMapOvr>
-  <mc:AlternateContent xmlns:mc="http://schemas.openxmlformats.org/markup-compatibility/2006">
-    <mc:Choice xmlns:p14="http://schemas.microsoft.com/office/powerpoint/2010/main" Requires="p14">
+  <mc:AlternateContent xmlns:mc="http://schemas.openxmlformats.org/markup-compatibility/2006" xmlns:p14="http://schemas.microsoft.com/office/powerpoint/2010/main">
+    <mc:Choice Requires="p14">
       <p:transition spd="slow" p14:dur="1250">
         <p:fade/>
       </p:transition>
     </mc:Choice>
-    <mc:Fallback>
+    <mc:Fallback xmlns="">
       <p:transition spd="slow">
         <p:fade/>
       </p:transition>
@@ -2639,7 +2639,7 @@
           <a:p>
             <a:fld id="{5BCAD085-E8A6-8845-BD4E-CB4CCA059FC4}" type="datetimeFigureOut">
               <a:rPr lang="en-US" smtClean="0"/>
-              <a:t>3/4/2026</a:t>
+              <a:t>3/5/2026</a:t>
             </a:fld>
             <a:endParaRPr lang="en-US"/>
           </a:p>
@@ -2697,13 +2697,13 @@
   <p:clrMapOvr>
     <a:masterClrMapping/>
   </p:clrMapOvr>
-  <mc:AlternateContent xmlns:mc="http://schemas.openxmlformats.org/markup-compatibility/2006">
-    <mc:Choice xmlns:p14="http://schemas.microsoft.com/office/powerpoint/2010/main" Requires="p14">
+  <mc:AlternateContent xmlns:mc="http://schemas.openxmlformats.org/markup-compatibility/2006" xmlns:p14="http://schemas.microsoft.com/office/powerpoint/2010/main">
+    <mc:Choice Requires="p14">
       <p:transition spd="slow" p14:dur="1250">
         <p:fade/>
       </p:transition>
     </mc:Choice>
-    <mc:Fallback>
+    <mc:Fallback xmlns="">
       <p:transition spd="slow">
         <p:fade/>
       </p:transition>
@@ -2862,7 +2862,7 @@
           <a:p>
             <a:fld id="{5BCAD085-E8A6-8845-BD4E-CB4CCA059FC4}" type="datetimeFigureOut">
               <a:rPr lang="en-US" smtClean="0"/>
-              <a:t>3/4/2026</a:t>
+              <a:t>3/5/2026</a:t>
             </a:fld>
             <a:endParaRPr lang="en-US"/>
           </a:p>
@@ -2967,13 +2967,13 @@
     <p:sldLayoutId id="2147483658" r:id="rId10"/>
     <p:sldLayoutId id="2147483659" r:id="rId11"/>
   </p:sldLayoutIdLst>
-  <mc:AlternateContent xmlns:mc="http://schemas.openxmlformats.org/markup-compatibility/2006">
-    <mc:Choice xmlns:p14="http://schemas.microsoft.com/office/powerpoint/2010/main" Requires="p14">
+  <mc:AlternateContent xmlns:mc="http://schemas.openxmlformats.org/markup-compatibility/2006" xmlns:p14="http://schemas.microsoft.com/office/powerpoint/2010/main">
+    <mc:Choice Requires="p14">
       <p:transition spd="slow" p14:dur="1250">
         <p:fade/>
       </p:transition>
     </mc:Choice>
-    <mc:Fallback>
+    <mc:Fallback xmlns="">
       <p:transition spd="slow">
         <p:fade/>
       </p:transition>
@@ -5698,13 +5698,13 @@
   <p:clrMapOvr>
     <a:masterClrMapping/>
   </p:clrMapOvr>
-  <mc:AlternateContent xmlns:mc="http://schemas.openxmlformats.org/markup-compatibility/2006">
-    <mc:Choice xmlns:p14="http://schemas.microsoft.com/office/powerpoint/2010/main" Requires="p14">
+  <mc:AlternateContent xmlns:mc="http://schemas.openxmlformats.org/markup-compatibility/2006" xmlns:p14="http://schemas.microsoft.com/office/powerpoint/2010/main">
+    <mc:Choice Requires="p14">
       <p:transition spd="slow" p14:dur="1250">
         <p:fade/>
       </p:transition>
     </mc:Choice>
-    <mc:Fallback>
+    <mc:Fallback xmlns="">
       <p:transition spd="slow">
         <p:fade/>
       </p:transition>
@@ -9120,13 +9120,13 @@
   <p:clrMapOvr>
     <a:masterClrMapping/>
   </p:clrMapOvr>
-  <mc:AlternateContent xmlns:mc="http://schemas.openxmlformats.org/markup-compatibility/2006">
-    <mc:Choice xmlns:p14="http://schemas.microsoft.com/office/powerpoint/2010/main" Requires="p14">
+  <mc:AlternateContent xmlns:mc="http://schemas.openxmlformats.org/markup-compatibility/2006" xmlns:p14="http://schemas.microsoft.com/office/powerpoint/2010/main">
+    <mc:Choice Requires="p14">
       <p:transition spd="slow" p14:dur="1250">
         <p:fade/>
       </p:transition>
     </mc:Choice>
-    <mc:Fallback>
+    <mc:Fallback xmlns="">
       <p:transition spd="slow">
         <p:fade/>
       </p:transition>
@@ -13369,13 +13369,13 @@
   <p:clrMapOvr>
     <a:masterClrMapping/>
   </p:clrMapOvr>
-  <mc:AlternateContent xmlns:mc="http://schemas.openxmlformats.org/markup-compatibility/2006">
-    <mc:Choice xmlns:p14="http://schemas.microsoft.com/office/powerpoint/2010/main" Requires="p14">
+  <mc:AlternateContent xmlns:mc="http://schemas.openxmlformats.org/markup-compatibility/2006" xmlns:p14="http://schemas.microsoft.com/office/powerpoint/2010/main">
+    <mc:Choice Requires="p14">
       <p:transition spd="slow" p14:dur="1250">
         <p:fade/>
       </p:transition>
     </mc:Choice>
-    <mc:Fallback>
+    <mc:Fallback xmlns="">
       <p:transition spd="slow">
         <p:fade/>
       </p:transition>
@@ -15160,13 +15160,13 @@
   <p:clrMapOvr>
     <a:masterClrMapping/>
   </p:clrMapOvr>
-  <mc:AlternateContent xmlns:mc="http://schemas.openxmlformats.org/markup-compatibility/2006">
-    <mc:Choice xmlns:p14="http://schemas.microsoft.com/office/powerpoint/2010/main" Requires="p14">
+  <mc:AlternateContent xmlns:mc="http://schemas.openxmlformats.org/markup-compatibility/2006" xmlns:p14="http://schemas.microsoft.com/office/powerpoint/2010/main">
+    <mc:Choice Requires="p14">
       <p:transition spd="slow" p14:dur="1250">
         <p:fade/>
       </p:transition>
     </mc:Choice>
-    <mc:Fallback>
+    <mc:Fallback xmlns="">
       <p:transition spd="slow">
         <p:fade/>
       </p:transition>
@@ -18396,13 +18396,13 @@
   <p:clrMapOvr>
     <a:masterClrMapping/>
   </p:clrMapOvr>
-  <mc:AlternateContent xmlns:mc="http://schemas.openxmlformats.org/markup-compatibility/2006">
-    <mc:Choice xmlns:p14="http://schemas.microsoft.com/office/powerpoint/2010/main" Requires="p14">
+  <mc:AlternateContent xmlns:mc="http://schemas.openxmlformats.org/markup-compatibility/2006" xmlns:p14="http://schemas.microsoft.com/office/powerpoint/2010/main">
+    <mc:Choice Requires="p14">
       <p:transition spd="slow" p14:dur="1250">
         <p:fade/>
       </p:transition>
     </mc:Choice>
-    <mc:Fallback>
+    <mc:Fallback xmlns="">
       <p:transition spd="slow">
         <p:fade/>
       </p:transition>
@@ -19764,13 +19764,13 @@
   <p:clrMapOvr>
     <a:masterClrMapping/>
   </p:clrMapOvr>
-  <mc:AlternateContent xmlns:mc="http://schemas.openxmlformats.org/markup-compatibility/2006">
-    <mc:Choice xmlns:p14="http://schemas.microsoft.com/office/powerpoint/2010/main" Requires="p14">
+  <mc:AlternateContent xmlns:mc="http://schemas.openxmlformats.org/markup-compatibility/2006" xmlns:p14="http://schemas.microsoft.com/office/powerpoint/2010/main">
+    <mc:Choice Requires="p14">
       <p:transition spd="slow" p14:dur="1250">
         <p:fade/>
       </p:transition>
     </mc:Choice>
-    <mc:Fallback>
+    <mc:Fallback xmlns="">
       <p:transition spd="slow">
         <p:fade/>
       </p:transition>
@@ -19882,12 +19882,20 @@
           <a:p>
             <a:pPr algn="l"/>
             <a:r>
+              <a:rPr lang="en-IN" b="1" dirty="0">
+                <a:solidFill>
+                  <a:srgbClr val="FFFFFF"/>
+                </a:solidFill>
+              </a:rPr>
+              <a:t>Final</a:t>
+            </a:r>
+            <a:r>
               <a:rPr sz="1800" b="1" i="0" dirty="0">
                 <a:solidFill>
                   <a:srgbClr val="FFFFFF"/>
                 </a:solidFill>
               </a:rPr>
-              <a:t>Demo Dashboard </a:t>
+              <a:t> Dashboard </a:t>
             </a:r>
             <a:r>
               <a:rPr lang="en-IN" sz="1800" b="1" i="0" dirty="0">
@@ -20016,10 +20024,10 @@
       </p:sp>
       <p:pic>
         <p:nvPicPr>
-          <p:cNvPr id="3" name="Picture 2">
+          <p:cNvPr id="5" name="Picture 4">
             <a:extLst>
               <a:ext uri="{FF2B5EF4-FFF2-40B4-BE49-F238E27FC236}">
-                <a16:creationId xmlns:a16="http://schemas.microsoft.com/office/drawing/2014/main" id="{56D5E6F4-782A-D263-7ACA-1F22258580CD}"/>
+                <a16:creationId xmlns:a16="http://schemas.microsoft.com/office/drawing/2014/main" id="{2230FB4D-7680-4202-B86A-0AE100051D69}"/>
               </a:ext>
             </a:extLst>
           </p:cNvPr>
@@ -20036,8 +20044,8 @@
         </p:blipFill>
         <p:spPr>
           <a:xfrm>
-            <a:off x="0" y="784815"/>
-            <a:ext cx="14630400" cy="7444785"/>
+            <a:off x="0" y="762000"/>
+            <a:ext cx="14630400" cy="7467600"/>
           </a:xfrm>
           <a:prstGeom prst="rect">
             <a:avLst/>
@@ -20054,13 +20062,13 @@
   <p:clrMapOvr>
     <a:masterClrMapping/>
   </p:clrMapOvr>
-  <mc:AlternateContent xmlns:mc="http://schemas.openxmlformats.org/markup-compatibility/2006">
-    <mc:Choice xmlns:p14="http://schemas.microsoft.com/office/powerpoint/2010/main" Requires="p14">
+  <mc:AlternateContent xmlns:mc="http://schemas.openxmlformats.org/markup-compatibility/2006" xmlns:p14="http://schemas.microsoft.com/office/powerpoint/2010/main">
+    <mc:Choice Requires="p14">
       <p:transition spd="slow" p14:dur="1250">
         <p:fade/>
       </p:transition>
     </mc:Choice>
-    <mc:Fallback>
+    <mc:Fallback xmlns="">
       <p:transition spd="slow">
         <p:fade/>
       </p:transition>
@@ -22594,13 +22602,13 @@
   <p:clrMapOvr>
     <a:masterClrMapping/>
   </p:clrMapOvr>
-  <mc:AlternateContent xmlns:mc="http://schemas.openxmlformats.org/markup-compatibility/2006">
-    <mc:Choice xmlns:p14="http://schemas.microsoft.com/office/powerpoint/2010/main" Requires="p14">
+  <mc:AlternateContent xmlns:mc="http://schemas.openxmlformats.org/markup-compatibility/2006" xmlns:p14="http://schemas.microsoft.com/office/powerpoint/2010/main">
+    <mc:Choice Requires="p14">
       <p:transition spd="slow" p14:dur="1250">
         <p:fade/>
       </p:transition>
     </mc:Choice>
-    <mc:Fallback>
+    <mc:Fallback xmlns="">
       <p:transition spd="slow">
         <p:fade/>
       </p:transition>
@@ -24093,13 +24101,13 @@
   <p:clrMapOvr>
     <a:masterClrMapping/>
   </p:clrMapOvr>
-  <mc:AlternateContent xmlns:mc="http://schemas.openxmlformats.org/markup-compatibility/2006">
-    <mc:Choice xmlns:p14="http://schemas.microsoft.com/office/powerpoint/2010/main" Requires="p14">
+  <mc:AlternateContent xmlns:mc="http://schemas.openxmlformats.org/markup-compatibility/2006" xmlns:p14="http://schemas.microsoft.com/office/powerpoint/2010/main">
+    <mc:Choice Requires="p14">
       <p:transition spd="slow" p14:dur="1250">
         <p:fade/>
       </p:transition>
     </mc:Choice>
-    <mc:Fallback>
+    <mc:Fallback xmlns="">
       <p:transition spd="slow">
         <p:fade/>
       </p:transition>
@@ -26287,13 +26295,13 @@
   <p:clrMapOvr>
     <a:masterClrMapping/>
   </p:clrMapOvr>
-  <mc:AlternateContent xmlns:mc="http://schemas.openxmlformats.org/markup-compatibility/2006">
-    <mc:Choice xmlns:p14="http://schemas.microsoft.com/office/powerpoint/2010/main" Requires="p14">
+  <mc:AlternateContent xmlns:mc="http://schemas.openxmlformats.org/markup-compatibility/2006" xmlns:p14="http://schemas.microsoft.com/office/powerpoint/2010/main">
+    <mc:Choice Requires="p14">
       <p:transition spd="slow" p14:dur="1250">
         <p:fade/>
       </p:transition>
     </mc:Choice>
-    <mc:Fallback>
+    <mc:Fallback xmlns="">
       <p:transition spd="slow">
         <p:fade/>
       </p:transition>
@@ -28385,13 +28393,13 @@
   <p:clrMapOvr>
     <a:masterClrMapping/>
   </p:clrMapOvr>
-  <mc:AlternateContent xmlns:mc="http://schemas.openxmlformats.org/markup-compatibility/2006">
-    <mc:Choice xmlns:p14="http://schemas.microsoft.com/office/powerpoint/2010/main" Requires="p14">
+  <mc:AlternateContent xmlns:mc="http://schemas.openxmlformats.org/markup-compatibility/2006" xmlns:p14="http://schemas.microsoft.com/office/powerpoint/2010/main">
+    <mc:Choice Requires="p14">
       <p:transition spd="slow" p14:dur="1250">
         <p:fade/>
       </p:transition>
     </mc:Choice>
-    <mc:Fallback>
+    <mc:Fallback xmlns="">
       <p:transition spd="slow">
         <p:fade/>
       </p:transition>
@@ -30500,13 +30508,13 @@
   <p:clrMapOvr>
     <a:masterClrMapping/>
   </p:clrMapOvr>
-  <mc:AlternateContent xmlns:mc="http://schemas.openxmlformats.org/markup-compatibility/2006">
-    <mc:Choice xmlns:p14="http://schemas.microsoft.com/office/powerpoint/2010/main" Requires="p14">
+  <mc:AlternateContent xmlns:mc="http://schemas.openxmlformats.org/markup-compatibility/2006" xmlns:p14="http://schemas.microsoft.com/office/powerpoint/2010/main">
+    <mc:Choice Requires="p14">
       <p:transition spd="slow" p14:dur="1250">
         <p:fade/>
       </p:transition>
     </mc:Choice>
-    <mc:Fallback>
+    <mc:Fallback xmlns="">
       <p:transition spd="slow">
         <p:fade/>
       </p:transition>
@@ -32514,13 +32522,13 @@
   <p:clrMapOvr>
     <a:masterClrMapping/>
   </p:clrMapOvr>
-  <mc:AlternateContent xmlns:mc="http://schemas.openxmlformats.org/markup-compatibility/2006">
-    <mc:Choice xmlns:p14="http://schemas.microsoft.com/office/powerpoint/2010/main" Requires="p14">
+  <mc:AlternateContent xmlns:mc="http://schemas.openxmlformats.org/markup-compatibility/2006" xmlns:p14="http://schemas.microsoft.com/office/powerpoint/2010/main">
+    <mc:Choice Requires="p14">
       <p:transition spd="slow" p14:dur="1250">
         <p:fade/>
       </p:transition>
     </mc:Choice>
-    <mc:Fallback>
+    <mc:Fallback xmlns="">
       <p:transition spd="slow">
         <p:fade/>
       </p:transition>
@@ -34632,13 +34640,13 @@
   <p:clrMapOvr>
     <a:masterClrMapping/>
   </p:clrMapOvr>
-  <mc:AlternateContent xmlns:mc="http://schemas.openxmlformats.org/markup-compatibility/2006">
-    <mc:Choice xmlns:p14="http://schemas.microsoft.com/office/powerpoint/2010/main" Requires="p14">
+  <mc:AlternateContent xmlns:mc="http://schemas.openxmlformats.org/markup-compatibility/2006" xmlns:p14="http://schemas.microsoft.com/office/powerpoint/2010/main">
+    <mc:Choice Requires="p14">
       <p:transition spd="slow" p14:dur="1250">
         <p:fade/>
       </p:transition>
     </mc:Choice>
-    <mc:Fallback>
+    <mc:Fallback xmlns="">
       <p:transition spd="slow">
         <p:fade/>
       </p:transition>
@@ -38066,13 +38074,13 @@
   <p:clrMapOvr>
     <a:masterClrMapping/>
   </p:clrMapOvr>
-  <mc:AlternateContent xmlns:mc="http://schemas.openxmlformats.org/markup-compatibility/2006">
-    <mc:Choice xmlns:p14="http://schemas.microsoft.com/office/powerpoint/2010/main" Requires="p14">
+  <mc:AlternateContent xmlns:mc="http://schemas.openxmlformats.org/markup-compatibility/2006" xmlns:p14="http://schemas.microsoft.com/office/powerpoint/2010/main">
+    <mc:Choice Requires="p14">
       <p:transition spd="slow" p14:dur="1250">
         <p:fade/>
       </p:transition>
     </mc:Choice>
-    <mc:Fallback>
+    <mc:Fallback xmlns="">
       <p:transition spd="slow">
         <p:fade/>
       </p:transition>
@@ -41720,13 +41728,13 @@
   <p:clrMapOvr>
     <a:masterClrMapping/>
   </p:clrMapOvr>
-  <mc:AlternateContent xmlns:mc="http://schemas.openxmlformats.org/markup-compatibility/2006">
-    <mc:Choice xmlns:p14="http://schemas.microsoft.com/office/powerpoint/2010/main" Requires="p14">
+  <mc:AlternateContent xmlns:mc="http://schemas.openxmlformats.org/markup-compatibility/2006" xmlns:p14="http://schemas.microsoft.com/office/powerpoint/2010/main">
+    <mc:Choice Requires="p14">
       <p:transition spd="slow" p14:dur="1250">
         <p:fade/>
       </p:transition>
     </mc:Choice>
-    <mc:Fallback>
+    <mc:Fallback xmlns="">
       <p:transition spd="slow">
         <p:fade/>
       </p:transition>

</xml_diff>